<commit_message>
LP content principle: resource-on-the-page rule; T6W7 L1 LP v2 with particle model diagram
</commit_message>
<xml_diff>
--- a/Science/T6W7_L1_LP1_Scientist_States_of_Matter.pptx
+++ b/Science/T6W7_L1_LP1_Scientist_States_of_Matter.pptx
@@ -3178,20 +3178,44 @@
                 </a:solidFill>
                 <a:latin typeface="Twinkl Cursive Looped"/>
               </a:rPr>
-              <a:t>Sort each material into solid, liquid or gas. Write one reason for each, using the particle model to help you.</a:t>
-            </a:r>
-          </a:p>
-        </p:txBody>
-      </p:sp>
-      <p:sp>
-        <p:nvSpPr>
-          <p:cNvPr id="5" name="Rectangle 4"/>
+              <a:t>Sort each material into solid, liquid or gas. Write one reason for each, using the particle model below to help you.</a:t>
+            </a:r>
+          </a:p>
+        </p:txBody>
+      </p:sp>
+      <p:pic>
+        <p:nvPicPr>
+          <p:cNvPr id="5" name="Picture 4" descr="particle_model.png"/>
+          <p:cNvPicPr>
+            <a:picLocks noChangeAspect="1"/>
+          </p:cNvPicPr>
+          <p:nvPr/>
+        </p:nvPicPr>
+        <p:blipFill>
+          <a:blip r:embed="rId3"/>
+          <a:stretch>
+            <a:fillRect/>
+          </a:stretch>
+        </p:blipFill>
+        <p:spPr>
+          <a:xfrm>
+            <a:off x="2568892" y="2338323"/>
+            <a:ext cx="1720215" cy="960120"/>
+          </a:xfrm>
+          <a:prstGeom prst="rect">
+            <a:avLst/>
+          </a:prstGeom>
+        </p:spPr>
+      </p:pic>
+      <p:sp>
+        <p:nvSpPr>
+          <p:cNvPr id="6" name="Rectangle 5"/>
           <p:cNvSpPr/>
           <p:nvPr/>
         </p:nvSpPr>
         <p:spPr>
           <a:xfrm>
-            <a:off x="228600" y="2338323"/>
+            <a:off x="228600" y="3389883"/>
             <a:ext cx="1664208" cy="256032"/>
           </a:xfrm>
           <a:prstGeom prst="rect">
@@ -3228,13 +3252,13 @@
       </p:sp>
       <p:sp>
         <p:nvSpPr>
-          <p:cNvPr id="6" name="TextBox 5"/>
+          <p:cNvPr id="7" name="TextBox 6"/>
           <p:cNvSpPr txBox="1"/>
           <p:nvPr/>
         </p:nvSpPr>
         <p:spPr>
           <a:xfrm>
-            <a:off x="265176" y="2365755"/>
+            <a:off x="265176" y="3417315"/>
             <a:ext cx="1591056" cy="201168"/>
           </a:xfrm>
           <a:prstGeom prst="rect">
@@ -3263,13 +3287,13 @@
       </p:sp>
       <p:sp>
         <p:nvSpPr>
-          <p:cNvPr id="7" name="Rectangle 6"/>
+          <p:cNvPr id="8" name="Rectangle 7"/>
           <p:cNvSpPr/>
           <p:nvPr/>
         </p:nvSpPr>
         <p:spPr>
           <a:xfrm>
-            <a:off x="1892808" y="2338323"/>
+            <a:off x="1892808" y="3389883"/>
             <a:ext cx="896112" cy="256032"/>
           </a:xfrm>
           <a:prstGeom prst="rect">
@@ -3306,13 +3330,13 @@
       </p:sp>
       <p:sp>
         <p:nvSpPr>
-          <p:cNvPr id="8" name="TextBox 7"/>
+          <p:cNvPr id="9" name="TextBox 8"/>
           <p:cNvSpPr txBox="1"/>
           <p:nvPr/>
         </p:nvSpPr>
         <p:spPr>
           <a:xfrm>
-            <a:off x="1929384" y="2365755"/>
+            <a:off x="1929384" y="3417315"/>
             <a:ext cx="822960" cy="201168"/>
           </a:xfrm>
           <a:prstGeom prst="rect">
@@ -3341,13 +3365,13 @@
       </p:sp>
       <p:sp>
         <p:nvSpPr>
-          <p:cNvPr id="9" name="Rectangle 8"/>
+          <p:cNvPr id="10" name="Rectangle 9"/>
           <p:cNvSpPr/>
           <p:nvPr/>
         </p:nvSpPr>
         <p:spPr>
           <a:xfrm>
-            <a:off x="2788920" y="2338323"/>
+            <a:off x="2788920" y="3389883"/>
             <a:ext cx="3840480" cy="256032"/>
           </a:xfrm>
           <a:prstGeom prst="rect">
@@ -3384,13 +3408,13 @@
       </p:sp>
       <p:sp>
         <p:nvSpPr>
-          <p:cNvPr id="10" name="TextBox 9"/>
+          <p:cNvPr id="11" name="TextBox 10"/>
           <p:cNvSpPr txBox="1"/>
           <p:nvPr/>
         </p:nvSpPr>
         <p:spPr>
           <a:xfrm>
-            <a:off x="2825496" y="2365755"/>
+            <a:off x="2825496" y="3417315"/>
             <a:ext cx="3767328" cy="201168"/>
           </a:xfrm>
           <a:prstGeom prst="rect">
@@ -3419,14 +3443,14 @@
       </p:sp>
       <p:sp>
         <p:nvSpPr>
-          <p:cNvPr id="11" name="Rectangle 10"/>
+          <p:cNvPr id="12" name="Rectangle 11"/>
           <p:cNvSpPr/>
           <p:nvPr/>
         </p:nvSpPr>
         <p:spPr>
           <a:xfrm>
-            <a:off x="228600" y="2594355"/>
-            <a:ext cx="1664208" cy="384048"/>
+            <a:off x="228600" y="3645915"/>
+            <a:ext cx="1664208" cy="329184"/>
           </a:xfrm>
           <a:prstGeom prst="rect">
             <a:avLst/>
@@ -3464,14 +3488,14 @@
       </p:sp>
       <p:sp>
         <p:nvSpPr>
-          <p:cNvPr id="12" name="TextBox 11"/>
+          <p:cNvPr id="13" name="TextBox 12"/>
           <p:cNvSpPr txBox="1"/>
           <p:nvPr/>
         </p:nvSpPr>
         <p:spPr>
           <a:xfrm>
-            <a:off x="265176" y="2630931"/>
-            <a:ext cx="1591056" cy="310896"/>
+            <a:off x="265176" y="3682491"/>
+            <a:ext cx="1591056" cy="256031"/>
           </a:xfrm>
           <a:prstGeom prst="rect">
             <a:avLst/>
@@ -3499,14 +3523,14 @@
       </p:sp>
       <p:sp>
         <p:nvSpPr>
-          <p:cNvPr id="13" name="Rectangle 12"/>
+          <p:cNvPr id="14" name="Rectangle 13"/>
           <p:cNvSpPr/>
           <p:nvPr/>
         </p:nvSpPr>
         <p:spPr>
           <a:xfrm>
-            <a:off x="1892808" y="2594355"/>
-            <a:ext cx="896112" cy="384048"/>
+            <a:off x="1892808" y="3645915"/>
+            <a:ext cx="896112" cy="329184"/>
           </a:xfrm>
           <a:prstGeom prst="rect">
             <a:avLst/>
@@ -3544,14 +3568,14 @@
       </p:sp>
       <p:sp>
         <p:nvSpPr>
-          <p:cNvPr id="14" name="Rectangle 13"/>
+          <p:cNvPr id="15" name="Rectangle 14"/>
           <p:cNvSpPr/>
           <p:nvPr/>
         </p:nvSpPr>
         <p:spPr>
           <a:xfrm>
-            <a:off x="2788920" y="2594355"/>
-            <a:ext cx="3840480" cy="384048"/>
+            <a:off x="2788920" y="3645915"/>
+            <a:ext cx="3840480" cy="329184"/>
           </a:xfrm>
           <a:prstGeom prst="rect">
             <a:avLst/>
@@ -3589,14 +3613,14 @@
       </p:sp>
       <p:sp>
         <p:nvSpPr>
-          <p:cNvPr id="15" name="Rectangle 14"/>
+          <p:cNvPr id="16" name="Rectangle 15"/>
           <p:cNvSpPr/>
           <p:nvPr/>
         </p:nvSpPr>
         <p:spPr>
           <a:xfrm>
-            <a:off x="228600" y="2978403"/>
-            <a:ext cx="1664208" cy="384048"/>
+            <a:off x="228600" y="3975099"/>
+            <a:ext cx="1664208" cy="329184"/>
           </a:xfrm>
           <a:prstGeom prst="rect">
             <a:avLst/>
@@ -3634,14 +3658,14 @@
       </p:sp>
       <p:sp>
         <p:nvSpPr>
-          <p:cNvPr id="16" name="TextBox 15"/>
+          <p:cNvPr id="17" name="TextBox 16"/>
           <p:cNvSpPr txBox="1"/>
           <p:nvPr/>
         </p:nvSpPr>
         <p:spPr>
           <a:xfrm>
-            <a:off x="265176" y="3014979"/>
-            <a:ext cx="1591056" cy="310896"/>
+            <a:off x="265176" y="4011675"/>
+            <a:ext cx="1591056" cy="256031"/>
           </a:xfrm>
           <a:prstGeom prst="rect">
             <a:avLst/>
@@ -3669,14 +3693,14 @@
       </p:sp>
       <p:sp>
         <p:nvSpPr>
-          <p:cNvPr id="17" name="Rectangle 16"/>
+          <p:cNvPr id="18" name="Rectangle 17"/>
           <p:cNvSpPr/>
           <p:nvPr/>
         </p:nvSpPr>
         <p:spPr>
           <a:xfrm>
-            <a:off x="1892808" y="2978403"/>
-            <a:ext cx="896112" cy="384048"/>
+            <a:off x="1892808" y="3975099"/>
+            <a:ext cx="896112" cy="329184"/>
           </a:xfrm>
           <a:prstGeom prst="rect">
             <a:avLst/>
@@ -3714,14 +3738,14 @@
       </p:sp>
       <p:sp>
         <p:nvSpPr>
-          <p:cNvPr id="18" name="Rectangle 17"/>
+          <p:cNvPr id="19" name="Rectangle 18"/>
           <p:cNvSpPr/>
           <p:nvPr/>
         </p:nvSpPr>
         <p:spPr>
           <a:xfrm>
-            <a:off x="2788920" y="2978403"/>
-            <a:ext cx="3840480" cy="384048"/>
+            <a:off x="2788920" y="3975099"/>
+            <a:ext cx="3840480" cy="329184"/>
           </a:xfrm>
           <a:prstGeom prst="rect">
             <a:avLst/>
@@ -3759,14 +3783,14 @@
       </p:sp>
       <p:sp>
         <p:nvSpPr>
-          <p:cNvPr id="19" name="Rectangle 18"/>
+          <p:cNvPr id="20" name="Rectangle 19"/>
           <p:cNvSpPr/>
           <p:nvPr/>
         </p:nvSpPr>
         <p:spPr>
           <a:xfrm>
-            <a:off x="228600" y="3362451"/>
-            <a:ext cx="1664208" cy="384048"/>
+            <a:off x="228600" y="4304284"/>
+            <a:ext cx="1664208" cy="329184"/>
           </a:xfrm>
           <a:prstGeom prst="rect">
             <a:avLst/>
@@ -3804,14 +3828,14 @@
       </p:sp>
       <p:sp>
         <p:nvSpPr>
-          <p:cNvPr id="20" name="TextBox 19"/>
+          <p:cNvPr id="21" name="TextBox 20"/>
           <p:cNvSpPr txBox="1"/>
           <p:nvPr/>
         </p:nvSpPr>
         <p:spPr>
           <a:xfrm>
-            <a:off x="265176" y="3399027"/>
-            <a:ext cx="1591056" cy="310896"/>
+            <a:off x="265176" y="4340860"/>
+            <a:ext cx="1591056" cy="256031"/>
           </a:xfrm>
           <a:prstGeom prst="rect">
             <a:avLst/>
@@ -3839,14 +3863,14 @@
       </p:sp>
       <p:sp>
         <p:nvSpPr>
-          <p:cNvPr id="21" name="Rectangle 20"/>
+          <p:cNvPr id="22" name="Rectangle 21"/>
           <p:cNvSpPr/>
           <p:nvPr/>
         </p:nvSpPr>
         <p:spPr>
           <a:xfrm>
-            <a:off x="1892808" y="3362451"/>
-            <a:ext cx="896112" cy="384048"/>
+            <a:off x="1892808" y="4304284"/>
+            <a:ext cx="896112" cy="329184"/>
           </a:xfrm>
           <a:prstGeom prst="rect">
             <a:avLst/>
@@ -3884,14 +3908,14 @@
       </p:sp>
       <p:sp>
         <p:nvSpPr>
-          <p:cNvPr id="22" name="Rectangle 21"/>
+          <p:cNvPr id="23" name="Rectangle 22"/>
           <p:cNvSpPr/>
           <p:nvPr/>
         </p:nvSpPr>
         <p:spPr>
           <a:xfrm>
-            <a:off x="2788920" y="3362451"/>
-            <a:ext cx="3840480" cy="384048"/>
+            <a:off x="2788920" y="4304284"/>
+            <a:ext cx="3840480" cy="329184"/>
           </a:xfrm>
           <a:prstGeom prst="rect">
             <a:avLst/>
@@ -3929,14 +3953,14 @@
       </p:sp>
       <p:sp>
         <p:nvSpPr>
-          <p:cNvPr id="23" name="Rectangle 22"/>
+          <p:cNvPr id="24" name="Rectangle 23"/>
           <p:cNvSpPr/>
           <p:nvPr/>
         </p:nvSpPr>
         <p:spPr>
           <a:xfrm>
-            <a:off x="228600" y="3746499"/>
-            <a:ext cx="1664208" cy="384048"/>
+            <a:off x="228600" y="4633468"/>
+            <a:ext cx="1664208" cy="329184"/>
           </a:xfrm>
           <a:prstGeom prst="rect">
             <a:avLst/>
@@ -3974,14 +3998,14 @@
       </p:sp>
       <p:sp>
         <p:nvSpPr>
-          <p:cNvPr id="24" name="TextBox 23"/>
+          <p:cNvPr id="25" name="TextBox 24"/>
           <p:cNvSpPr txBox="1"/>
           <p:nvPr/>
         </p:nvSpPr>
         <p:spPr>
           <a:xfrm>
-            <a:off x="265176" y="3783075"/>
-            <a:ext cx="1591056" cy="310896"/>
+            <a:off x="265176" y="4670044"/>
+            <a:ext cx="1591056" cy="256031"/>
           </a:xfrm>
           <a:prstGeom prst="rect">
             <a:avLst/>
@@ -4009,14 +4033,14 @@
       </p:sp>
       <p:sp>
         <p:nvSpPr>
-          <p:cNvPr id="25" name="Rectangle 24"/>
+          <p:cNvPr id="26" name="Rectangle 25"/>
           <p:cNvSpPr/>
           <p:nvPr/>
         </p:nvSpPr>
         <p:spPr>
           <a:xfrm>
-            <a:off x="1892808" y="3746499"/>
-            <a:ext cx="896112" cy="384048"/>
+            <a:off x="1892808" y="4633468"/>
+            <a:ext cx="896112" cy="329184"/>
           </a:xfrm>
           <a:prstGeom prst="rect">
             <a:avLst/>
@@ -4054,14 +4078,14 @@
       </p:sp>
       <p:sp>
         <p:nvSpPr>
-          <p:cNvPr id="26" name="Rectangle 25"/>
+          <p:cNvPr id="27" name="Rectangle 26"/>
           <p:cNvSpPr/>
           <p:nvPr/>
         </p:nvSpPr>
         <p:spPr>
           <a:xfrm>
-            <a:off x="2788920" y="3746499"/>
-            <a:ext cx="3840480" cy="384048"/>
+            <a:off x="2788920" y="4633468"/>
+            <a:ext cx="3840480" cy="329184"/>
           </a:xfrm>
           <a:prstGeom prst="rect">
             <a:avLst/>
@@ -4099,14 +4123,14 @@
       </p:sp>
       <p:sp>
         <p:nvSpPr>
-          <p:cNvPr id="27" name="Rectangle 26"/>
+          <p:cNvPr id="28" name="Rectangle 27"/>
           <p:cNvSpPr/>
           <p:nvPr/>
         </p:nvSpPr>
         <p:spPr>
           <a:xfrm>
-            <a:off x="228600" y="4130547"/>
-            <a:ext cx="1664208" cy="384048"/>
+            <a:off x="228600" y="4962652"/>
+            <a:ext cx="1664208" cy="329184"/>
           </a:xfrm>
           <a:prstGeom prst="rect">
             <a:avLst/>
@@ -4144,14 +4168,14 @@
       </p:sp>
       <p:sp>
         <p:nvSpPr>
-          <p:cNvPr id="28" name="TextBox 27"/>
+          <p:cNvPr id="29" name="TextBox 28"/>
           <p:cNvSpPr txBox="1"/>
           <p:nvPr/>
         </p:nvSpPr>
         <p:spPr>
           <a:xfrm>
-            <a:off x="265176" y="4167123"/>
-            <a:ext cx="1591056" cy="310896"/>
+            <a:off x="265176" y="4999228"/>
+            <a:ext cx="1591056" cy="256031"/>
           </a:xfrm>
           <a:prstGeom prst="rect">
             <a:avLst/>
@@ -4179,14 +4203,14 @@
       </p:sp>
       <p:sp>
         <p:nvSpPr>
-          <p:cNvPr id="29" name="Rectangle 28"/>
+          <p:cNvPr id="30" name="Rectangle 29"/>
           <p:cNvSpPr/>
           <p:nvPr/>
         </p:nvSpPr>
         <p:spPr>
           <a:xfrm>
-            <a:off x="1892808" y="4130547"/>
-            <a:ext cx="896112" cy="384048"/>
+            <a:off x="1892808" y="4962652"/>
+            <a:ext cx="896112" cy="329184"/>
           </a:xfrm>
           <a:prstGeom prst="rect">
             <a:avLst/>
@@ -4224,14 +4248,14 @@
       </p:sp>
       <p:sp>
         <p:nvSpPr>
-          <p:cNvPr id="30" name="Rectangle 29"/>
+          <p:cNvPr id="31" name="Rectangle 30"/>
           <p:cNvSpPr/>
           <p:nvPr/>
         </p:nvSpPr>
         <p:spPr>
           <a:xfrm>
-            <a:off x="2788920" y="4130547"/>
-            <a:ext cx="3840480" cy="384048"/>
+            <a:off x="2788920" y="4962652"/>
+            <a:ext cx="3840480" cy="329184"/>
           </a:xfrm>
           <a:prstGeom prst="rect">
             <a:avLst/>
@@ -4269,14 +4293,14 @@
       </p:sp>
       <p:sp>
         <p:nvSpPr>
-          <p:cNvPr id="31" name="Rectangle 30"/>
+          <p:cNvPr id="32" name="Rectangle 31"/>
           <p:cNvSpPr/>
           <p:nvPr/>
         </p:nvSpPr>
         <p:spPr>
           <a:xfrm>
-            <a:off x="228600" y="4514595"/>
-            <a:ext cx="1664208" cy="384048"/>
+            <a:off x="228600" y="5291836"/>
+            <a:ext cx="1664208" cy="329184"/>
           </a:xfrm>
           <a:prstGeom prst="rect">
             <a:avLst/>
@@ -4314,14 +4338,14 @@
       </p:sp>
       <p:sp>
         <p:nvSpPr>
-          <p:cNvPr id="32" name="TextBox 31"/>
+          <p:cNvPr id="33" name="TextBox 32"/>
           <p:cNvSpPr txBox="1"/>
           <p:nvPr/>
         </p:nvSpPr>
         <p:spPr>
           <a:xfrm>
-            <a:off x="265176" y="4551171"/>
-            <a:ext cx="1591056" cy="310896"/>
+            <a:off x="265176" y="5328412"/>
+            <a:ext cx="1591056" cy="256031"/>
           </a:xfrm>
           <a:prstGeom prst="rect">
             <a:avLst/>
@@ -4349,14 +4373,14 @@
       </p:sp>
       <p:sp>
         <p:nvSpPr>
-          <p:cNvPr id="33" name="Rectangle 32"/>
+          <p:cNvPr id="34" name="Rectangle 33"/>
           <p:cNvSpPr/>
           <p:nvPr/>
         </p:nvSpPr>
         <p:spPr>
           <a:xfrm>
-            <a:off x="1892808" y="4514595"/>
-            <a:ext cx="896112" cy="384048"/>
+            <a:off x="1892808" y="5291836"/>
+            <a:ext cx="896112" cy="329184"/>
           </a:xfrm>
           <a:prstGeom prst="rect">
             <a:avLst/>
@@ -4394,14 +4418,14 @@
       </p:sp>
       <p:sp>
         <p:nvSpPr>
-          <p:cNvPr id="34" name="Rectangle 33"/>
+          <p:cNvPr id="35" name="Rectangle 34"/>
           <p:cNvSpPr/>
           <p:nvPr/>
         </p:nvSpPr>
         <p:spPr>
           <a:xfrm>
-            <a:off x="2788920" y="4514595"/>
-            <a:ext cx="3840480" cy="384048"/>
+            <a:off x="2788920" y="5291836"/>
+            <a:ext cx="3840480" cy="329184"/>
           </a:xfrm>
           <a:prstGeom prst="rect">
             <a:avLst/>
@@ -4439,14 +4463,14 @@
       </p:sp>
       <p:sp>
         <p:nvSpPr>
-          <p:cNvPr id="35" name="Rectangle 34"/>
+          <p:cNvPr id="36" name="Rectangle 35"/>
           <p:cNvSpPr/>
           <p:nvPr/>
         </p:nvSpPr>
         <p:spPr>
           <a:xfrm>
-            <a:off x="228600" y="4898643"/>
-            <a:ext cx="1664208" cy="384048"/>
+            <a:off x="228600" y="5621020"/>
+            <a:ext cx="1664208" cy="329184"/>
           </a:xfrm>
           <a:prstGeom prst="rect">
             <a:avLst/>
@@ -4484,14 +4508,14 @@
       </p:sp>
       <p:sp>
         <p:nvSpPr>
-          <p:cNvPr id="36" name="TextBox 35"/>
+          <p:cNvPr id="37" name="TextBox 36"/>
           <p:cNvSpPr txBox="1"/>
           <p:nvPr/>
         </p:nvSpPr>
         <p:spPr>
           <a:xfrm>
-            <a:off x="265176" y="4935219"/>
-            <a:ext cx="1591056" cy="310896"/>
+            <a:off x="265176" y="5657596"/>
+            <a:ext cx="1591056" cy="256031"/>
           </a:xfrm>
           <a:prstGeom prst="rect">
             <a:avLst/>
@@ -4519,14 +4543,14 @@
       </p:sp>
       <p:sp>
         <p:nvSpPr>
-          <p:cNvPr id="37" name="Rectangle 36"/>
+          <p:cNvPr id="38" name="Rectangle 37"/>
           <p:cNvSpPr/>
           <p:nvPr/>
         </p:nvSpPr>
         <p:spPr>
           <a:xfrm>
-            <a:off x="1892808" y="4898643"/>
-            <a:ext cx="896112" cy="384048"/>
+            <a:off x="1892808" y="5621020"/>
+            <a:ext cx="896112" cy="329184"/>
           </a:xfrm>
           <a:prstGeom prst="rect">
             <a:avLst/>
@@ -4564,14 +4588,14 @@
       </p:sp>
       <p:sp>
         <p:nvSpPr>
-          <p:cNvPr id="38" name="Rectangle 37"/>
+          <p:cNvPr id="39" name="Rectangle 38"/>
           <p:cNvSpPr/>
           <p:nvPr/>
         </p:nvSpPr>
         <p:spPr>
           <a:xfrm>
-            <a:off x="2788920" y="4898643"/>
-            <a:ext cx="3840480" cy="384048"/>
+            <a:off x="2788920" y="5621020"/>
+            <a:ext cx="3840480" cy="329184"/>
           </a:xfrm>
           <a:prstGeom prst="rect">
             <a:avLst/>
@@ -4609,14 +4633,14 @@
       </p:sp>
       <p:sp>
         <p:nvSpPr>
-          <p:cNvPr id="39" name="Rectangle 38"/>
+          <p:cNvPr id="40" name="Rectangle 39"/>
           <p:cNvSpPr/>
           <p:nvPr/>
         </p:nvSpPr>
         <p:spPr>
           <a:xfrm>
-            <a:off x="228600" y="5282691"/>
-            <a:ext cx="1664208" cy="384048"/>
+            <a:off x="228600" y="5950204"/>
+            <a:ext cx="1664208" cy="329184"/>
           </a:xfrm>
           <a:prstGeom prst="rect">
             <a:avLst/>
@@ -4654,14 +4678,14 @@
       </p:sp>
       <p:sp>
         <p:nvSpPr>
-          <p:cNvPr id="40" name="TextBox 39"/>
+          <p:cNvPr id="41" name="TextBox 40"/>
           <p:cNvSpPr txBox="1"/>
           <p:nvPr/>
         </p:nvSpPr>
         <p:spPr>
           <a:xfrm>
-            <a:off x="265176" y="5319267"/>
-            <a:ext cx="1591056" cy="310896"/>
+            <a:off x="265176" y="5986780"/>
+            <a:ext cx="1591056" cy="256031"/>
           </a:xfrm>
           <a:prstGeom prst="rect">
             <a:avLst/>
@@ -4689,14 +4713,14 @@
       </p:sp>
       <p:sp>
         <p:nvSpPr>
-          <p:cNvPr id="41" name="Rectangle 40"/>
+          <p:cNvPr id="42" name="Rectangle 41"/>
           <p:cNvSpPr/>
           <p:nvPr/>
         </p:nvSpPr>
         <p:spPr>
           <a:xfrm>
-            <a:off x="1892808" y="5282691"/>
-            <a:ext cx="896112" cy="384048"/>
+            <a:off x="1892808" y="5950204"/>
+            <a:ext cx="896112" cy="329184"/>
           </a:xfrm>
           <a:prstGeom prst="rect">
             <a:avLst/>
@@ -4734,14 +4758,14 @@
       </p:sp>
       <p:sp>
         <p:nvSpPr>
-          <p:cNvPr id="42" name="Rectangle 41"/>
+          <p:cNvPr id="43" name="Rectangle 42"/>
           <p:cNvSpPr/>
           <p:nvPr/>
         </p:nvSpPr>
         <p:spPr>
           <a:xfrm>
-            <a:off x="2788920" y="5282691"/>
-            <a:ext cx="3840480" cy="384048"/>
+            <a:off x="2788920" y="5950204"/>
+            <a:ext cx="3840480" cy="329184"/>
           </a:xfrm>
           <a:prstGeom prst="rect">
             <a:avLst/>
@@ -4779,13 +4803,13 @@
       </p:sp>
       <p:sp>
         <p:nvSpPr>
-          <p:cNvPr id="43" name="TextBox 42"/>
+          <p:cNvPr id="44" name="TextBox 43"/>
           <p:cNvSpPr txBox="1"/>
           <p:nvPr/>
         </p:nvSpPr>
         <p:spPr>
           <a:xfrm>
-            <a:off x="228600" y="5776467"/>
+            <a:off x="228600" y="6389116"/>
             <a:ext cx="6400800" cy="219456"/>
           </a:xfrm>
           <a:prstGeom prst="rect">
@@ -4814,13 +4838,13 @@
       </p:sp>
       <p:sp>
         <p:nvSpPr>
-          <p:cNvPr id="44" name="TextBox 43"/>
+          <p:cNvPr id="45" name="TextBox 44"/>
           <p:cNvSpPr txBox="1"/>
           <p:nvPr/>
         </p:nvSpPr>
         <p:spPr>
           <a:xfrm>
-            <a:off x="228600" y="6050787"/>
+            <a:off x="228600" y="6663436"/>
             <a:ext cx="6400800" cy="173736"/>
           </a:xfrm>
           <a:prstGeom prst="rect">
@@ -4849,7 +4873,7 @@
       </p:sp>
       <p:sp>
         <p:nvSpPr>
-          <p:cNvPr id="45" name="Line45"/>
+          <p:cNvPr id="46" name="Line46"/>
           <p:cNvSpPr>
             <a:spLocks noGrp="1"/>
           </p:cNvSpPr>
@@ -4857,7 +4881,7 @@
         </p:nvSpPr>
         <p:spPr>
           <a:xfrm>
-            <a:off x="228600" y="6297675"/>
+            <a:off x="228600" y="6910324"/>
             <a:ext cx="6400800" cy="0"/>
           </a:xfrm>
           <a:prstGeom prst="line">
@@ -4879,7 +4903,7 @@
       </p:sp>
       <p:sp>
         <p:nvSpPr>
-          <p:cNvPr id="46" name="Line46"/>
+          <p:cNvPr id="47" name="Line47"/>
           <p:cNvSpPr>
             <a:spLocks noGrp="1"/>
           </p:cNvSpPr>
@@ -4887,7 +4911,7 @@
         </p:nvSpPr>
         <p:spPr>
           <a:xfrm>
-            <a:off x="228600" y="6585711"/>
+            <a:off x="228600" y="7198360"/>
             <a:ext cx="6400800" cy="0"/>
           </a:xfrm>
           <a:prstGeom prst="line">
@@ -4909,7 +4933,7 @@
       </p:sp>
       <p:sp>
         <p:nvSpPr>
-          <p:cNvPr id="47" name="Line47"/>
+          <p:cNvPr id="48" name="Line48"/>
           <p:cNvSpPr>
             <a:spLocks noGrp="1"/>
           </p:cNvSpPr>
@@ -4917,7 +4941,7 @@
         </p:nvSpPr>
         <p:spPr>
           <a:xfrm>
-            <a:off x="228600" y="6873747"/>
+            <a:off x="228600" y="7486396"/>
             <a:ext cx="6400800" cy="0"/>
           </a:xfrm>
           <a:prstGeom prst="line">
@@ -4939,13 +4963,13 @@
       </p:sp>
       <p:sp>
         <p:nvSpPr>
-          <p:cNvPr id="48" name="Rectangle 47"/>
+          <p:cNvPr id="49" name="Rectangle 48"/>
           <p:cNvSpPr/>
           <p:nvPr/>
         </p:nvSpPr>
         <p:spPr>
           <a:xfrm>
-            <a:off x="228600" y="7298943"/>
+            <a:off x="228600" y="7911592"/>
             <a:ext cx="6400800" cy="493776"/>
           </a:xfrm>
           <a:prstGeom prst="rect">
@@ -4984,13 +5008,13 @@
       </p:sp>
       <p:sp>
         <p:nvSpPr>
-          <p:cNvPr id="49" name="TextBox 48"/>
+          <p:cNvPr id="50" name="TextBox 49"/>
           <p:cNvSpPr txBox="1"/>
           <p:nvPr/>
         </p:nvSpPr>
         <p:spPr>
           <a:xfrm>
-            <a:off x="274320" y="7344664"/>
+            <a:off x="274320" y="7957312"/>
             <a:ext cx="6309360" cy="420624"/>
           </a:xfrm>
           <a:prstGeom prst="rect">

</xml_diff>

<commit_message>
T6W7 L1 LP v3: readability pass (bigger label-scaled-down/bigger text/bigger diagram, wrap-aware table rows, 0.8cm write-line gap rule)
</commit_message>
<xml_diff>
--- a/Science/T6W7_L1_LP1_Scientist_States_of_Matter.pptx
+++ b/Science/T6W7_L1_LP1_Scientist_States_of_Matter.pptx
@@ -3105,8 +3105,8 @@
         </p:blipFill>
         <p:spPr>
           <a:xfrm>
-            <a:off x="3063239" y="228600"/>
-            <a:ext cx="3566160" cy="1277619"/>
+            <a:off x="4108124" y="228600"/>
+            <a:ext cx="2521275" cy="712475"/>
           </a:xfrm>
           <a:prstGeom prst="rect">
             <a:avLst/>
@@ -3121,8 +3121,8 @@
         </p:nvSpPr>
         <p:spPr>
           <a:xfrm>
-            <a:off x="228600" y="1643379"/>
-            <a:ext cx="6400800" cy="219456"/>
+            <a:off x="228600" y="1078235"/>
+            <a:ext cx="6400800" cy="292607"/>
           </a:xfrm>
           <a:prstGeom prst="rect">
             <a:avLst/>
@@ -3137,7 +3137,7 @@
           <a:p>
             <a:pPr algn="l"/>
             <a:r>
-              <a:rPr sz="1200" b="1" i="0" u="none">
+              <a:rPr sz="1600" b="1" i="0" u="none">
                 <a:solidFill>
                   <a:srgbClr val="1798D3"/>
                 </a:solidFill>
@@ -3156,8 +3156,8 @@
         </p:nvSpPr>
         <p:spPr>
           <a:xfrm>
-            <a:off x="228600" y="1917699"/>
-            <a:ext cx="6400800" cy="347472"/>
+            <a:off x="228600" y="1425707"/>
+            <a:ext cx="6400800" cy="438912"/>
           </a:xfrm>
           <a:prstGeom prst="rect">
             <a:avLst/>
@@ -3172,7 +3172,7 @@
           <a:p>
             <a:pPr algn="l"/>
             <a:r>
-              <a:rPr sz="950" b="0" i="0" u="none">
+              <a:rPr sz="1200" b="0" i="0" u="none">
                 <a:solidFill>
                   <a:srgbClr val="1A1A1A"/>
                 </a:solidFill>
@@ -3199,8 +3199,8 @@
         </p:blipFill>
         <p:spPr>
           <a:xfrm>
-            <a:off x="2568892" y="2338323"/>
-            <a:ext cx="1720215" cy="960120"/>
+            <a:off x="2306764" y="1937771"/>
+            <a:ext cx="2244471" cy="1252728"/>
           </a:xfrm>
           <a:prstGeom prst="rect">
             <a:avLst/>
@@ -3215,8 +3215,8 @@
         </p:nvSpPr>
         <p:spPr>
           <a:xfrm>
-            <a:off x="228600" y="3389883"/>
-            <a:ext cx="1664208" cy="256032"/>
+            <a:off x="228600" y="3281939"/>
+            <a:ext cx="1664208" cy="297179"/>
           </a:xfrm>
           <a:prstGeom prst="rect">
             <a:avLst/>
@@ -3258,8 +3258,8 @@
         </p:nvSpPr>
         <p:spPr>
           <a:xfrm>
-            <a:off x="265176" y="3417315"/>
-            <a:ext cx="1591056" cy="201168"/>
+            <a:off x="265176" y="3309371"/>
+            <a:ext cx="1591056" cy="242315"/>
           </a:xfrm>
           <a:prstGeom prst="rect">
             <a:avLst/>
@@ -3274,7 +3274,7 @@
           <a:p>
             <a:pPr algn="l"/>
             <a:r>
-              <a:rPr sz="800" b="1" i="0" u="none">
+              <a:rPr sz="1000" b="1" i="0" u="none">
                 <a:solidFill>
                   <a:srgbClr val="FFFFFF"/>
                 </a:solidFill>
@@ -3293,8 +3293,8 @@
         </p:nvSpPr>
         <p:spPr>
           <a:xfrm>
-            <a:off x="1892808" y="3389883"/>
-            <a:ext cx="896112" cy="256032"/>
+            <a:off x="1892808" y="3281939"/>
+            <a:ext cx="896112" cy="297179"/>
           </a:xfrm>
           <a:prstGeom prst="rect">
             <a:avLst/>
@@ -3336,8 +3336,8 @@
         </p:nvSpPr>
         <p:spPr>
           <a:xfrm>
-            <a:off x="1929384" y="3417315"/>
-            <a:ext cx="822960" cy="201168"/>
+            <a:off x="1929384" y="3309371"/>
+            <a:ext cx="822960" cy="242315"/>
           </a:xfrm>
           <a:prstGeom prst="rect">
             <a:avLst/>
@@ -3352,7 +3352,7 @@
           <a:p>
             <a:pPr algn="l"/>
             <a:r>
-              <a:rPr sz="800" b="1" i="0" u="none">
+              <a:rPr sz="1000" b="1" i="0" u="none">
                 <a:solidFill>
                   <a:srgbClr val="FFFFFF"/>
                 </a:solidFill>
@@ -3371,8 +3371,8 @@
         </p:nvSpPr>
         <p:spPr>
           <a:xfrm>
-            <a:off x="2788920" y="3389883"/>
-            <a:ext cx="3840480" cy="256032"/>
+            <a:off x="2788920" y="3281939"/>
+            <a:ext cx="3840480" cy="297179"/>
           </a:xfrm>
           <a:prstGeom prst="rect">
             <a:avLst/>
@@ -3414,8 +3414,8 @@
         </p:nvSpPr>
         <p:spPr>
           <a:xfrm>
-            <a:off x="2825496" y="3417315"/>
-            <a:ext cx="3767328" cy="201168"/>
+            <a:off x="2825496" y="3309371"/>
+            <a:ext cx="3767328" cy="242315"/>
           </a:xfrm>
           <a:prstGeom prst="rect">
             <a:avLst/>
@@ -3430,7 +3430,7 @@
           <a:p>
             <a:pPr algn="l"/>
             <a:r>
-              <a:rPr sz="800" b="1" i="0" u="none">
+              <a:rPr sz="1000" b="1" i="0" u="none">
                 <a:solidFill>
                   <a:srgbClr val="FFFFFF"/>
                 </a:solidFill>
@@ -3449,8 +3449,8 @@
         </p:nvSpPr>
         <p:spPr>
           <a:xfrm>
-            <a:off x="228600" y="3645915"/>
-            <a:ext cx="1664208" cy="329184"/>
+            <a:off x="228600" y="3579119"/>
+            <a:ext cx="1664208" cy="361456"/>
           </a:xfrm>
           <a:prstGeom prst="rect">
             <a:avLst/>
@@ -3494,8 +3494,8 @@
         </p:nvSpPr>
         <p:spPr>
           <a:xfrm>
-            <a:off x="265176" y="3682491"/>
-            <a:ext cx="1591056" cy="256031"/>
+            <a:off x="265176" y="3615695"/>
+            <a:ext cx="1591056" cy="288304"/>
           </a:xfrm>
           <a:prstGeom prst="rect">
             <a:avLst/>
@@ -3510,7 +3510,7 @@
           <a:p>
             <a:pPr algn="l"/>
             <a:r>
-              <a:rPr sz="850" b="0" i="0" u="none">
+              <a:rPr sz="1000" b="0" i="0" u="none">
                 <a:solidFill>
                   <a:srgbClr val="1A1A1A"/>
                 </a:solidFill>
@@ -3529,8 +3529,8 @@
         </p:nvSpPr>
         <p:spPr>
           <a:xfrm>
-            <a:off x="1892808" y="3645915"/>
-            <a:ext cx="896112" cy="329184"/>
+            <a:off x="1892808" y="3579119"/>
+            <a:ext cx="896112" cy="361456"/>
           </a:xfrm>
           <a:prstGeom prst="rect">
             <a:avLst/>
@@ -3574,8 +3574,8 @@
         </p:nvSpPr>
         <p:spPr>
           <a:xfrm>
-            <a:off x="2788920" y="3645915"/>
-            <a:ext cx="3840480" cy="329184"/>
+            <a:off x="2788920" y="3579119"/>
+            <a:ext cx="3840480" cy="361456"/>
           </a:xfrm>
           <a:prstGeom prst="rect">
             <a:avLst/>
@@ -3619,8 +3619,8 @@
         </p:nvSpPr>
         <p:spPr>
           <a:xfrm>
-            <a:off x="228600" y="3975099"/>
-            <a:ext cx="1664208" cy="329184"/>
+            <a:off x="228600" y="3940576"/>
+            <a:ext cx="1664208" cy="361456"/>
           </a:xfrm>
           <a:prstGeom prst="rect">
             <a:avLst/>
@@ -3664,8 +3664,8 @@
         </p:nvSpPr>
         <p:spPr>
           <a:xfrm>
-            <a:off x="265176" y="4011675"/>
-            <a:ext cx="1591056" cy="256031"/>
+            <a:off x="265176" y="3977152"/>
+            <a:ext cx="1591056" cy="288304"/>
           </a:xfrm>
           <a:prstGeom prst="rect">
             <a:avLst/>
@@ -3680,7 +3680,7 @@
           <a:p>
             <a:pPr algn="l"/>
             <a:r>
-              <a:rPr sz="850" b="0" i="0" u="none">
+              <a:rPr sz="1000" b="0" i="0" u="none">
                 <a:solidFill>
                   <a:srgbClr val="1A1A1A"/>
                 </a:solidFill>
@@ -3699,8 +3699,8 @@
         </p:nvSpPr>
         <p:spPr>
           <a:xfrm>
-            <a:off x="1892808" y="3975099"/>
-            <a:ext cx="896112" cy="329184"/>
+            <a:off x="1892808" y="3940576"/>
+            <a:ext cx="896112" cy="361456"/>
           </a:xfrm>
           <a:prstGeom prst="rect">
             <a:avLst/>
@@ -3744,8 +3744,8 @@
         </p:nvSpPr>
         <p:spPr>
           <a:xfrm>
-            <a:off x="2788920" y="3975099"/>
-            <a:ext cx="3840480" cy="329184"/>
+            <a:off x="2788920" y="3940576"/>
+            <a:ext cx="3840480" cy="361456"/>
           </a:xfrm>
           <a:prstGeom prst="rect">
             <a:avLst/>
@@ -3789,8 +3789,8 @@
         </p:nvSpPr>
         <p:spPr>
           <a:xfrm>
-            <a:off x="228600" y="4304284"/>
-            <a:ext cx="1664208" cy="329184"/>
+            <a:off x="228600" y="4302033"/>
+            <a:ext cx="1664208" cy="361456"/>
           </a:xfrm>
           <a:prstGeom prst="rect">
             <a:avLst/>
@@ -3834,8 +3834,8 @@
         </p:nvSpPr>
         <p:spPr>
           <a:xfrm>
-            <a:off x="265176" y="4340860"/>
-            <a:ext cx="1591056" cy="256031"/>
+            <a:off x="265176" y="4338609"/>
+            <a:ext cx="1591056" cy="288304"/>
           </a:xfrm>
           <a:prstGeom prst="rect">
             <a:avLst/>
@@ -3850,7 +3850,7 @@
           <a:p>
             <a:pPr algn="l"/>
             <a:r>
-              <a:rPr sz="850" b="0" i="0" u="none">
+              <a:rPr sz="1000" b="0" i="0" u="none">
                 <a:solidFill>
                   <a:srgbClr val="1A1A1A"/>
                 </a:solidFill>
@@ -3869,8 +3869,8 @@
         </p:nvSpPr>
         <p:spPr>
           <a:xfrm>
-            <a:off x="1892808" y="4304284"/>
-            <a:ext cx="896112" cy="329184"/>
+            <a:off x="1892808" y="4302033"/>
+            <a:ext cx="896112" cy="361456"/>
           </a:xfrm>
           <a:prstGeom prst="rect">
             <a:avLst/>
@@ -3914,8 +3914,8 @@
         </p:nvSpPr>
         <p:spPr>
           <a:xfrm>
-            <a:off x="2788920" y="4304284"/>
-            <a:ext cx="3840480" cy="329184"/>
+            <a:off x="2788920" y="4302033"/>
+            <a:ext cx="3840480" cy="361456"/>
           </a:xfrm>
           <a:prstGeom prst="rect">
             <a:avLst/>
@@ -3959,8 +3959,8 @@
         </p:nvSpPr>
         <p:spPr>
           <a:xfrm>
-            <a:off x="228600" y="4633468"/>
-            <a:ext cx="1664208" cy="329184"/>
+            <a:off x="228600" y="4663490"/>
+            <a:ext cx="1664208" cy="361456"/>
           </a:xfrm>
           <a:prstGeom prst="rect">
             <a:avLst/>
@@ -4004,8 +4004,8 @@
         </p:nvSpPr>
         <p:spPr>
           <a:xfrm>
-            <a:off x="265176" y="4670044"/>
-            <a:ext cx="1591056" cy="256031"/>
+            <a:off x="265176" y="4700066"/>
+            <a:ext cx="1591056" cy="288304"/>
           </a:xfrm>
           <a:prstGeom prst="rect">
             <a:avLst/>
@@ -4020,7 +4020,7 @@
           <a:p>
             <a:pPr algn="l"/>
             <a:r>
-              <a:rPr sz="850" b="0" i="0" u="none">
+              <a:rPr sz="1000" b="0" i="0" u="none">
                 <a:solidFill>
                   <a:srgbClr val="1A1A1A"/>
                 </a:solidFill>
@@ -4039,8 +4039,8 @@
         </p:nvSpPr>
         <p:spPr>
           <a:xfrm>
-            <a:off x="1892808" y="4633468"/>
-            <a:ext cx="896112" cy="329184"/>
+            <a:off x="1892808" y="4663490"/>
+            <a:ext cx="896112" cy="361456"/>
           </a:xfrm>
           <a:prstGeom prst="rect">
             <a:avLst/>
@@ -4084,8 +4084,8 @@
         </p:nvSpPr>
         <p:spPr>
           <a:xfrm>
-            <a:off x="2788920" y="4633468"/>
-            <a:ext cx="3840480" cy="329184"/>
+            <a:off x="2788920" y="4663490"/>
+            <a:ext cx="3840480" cy="361456"/>
           </a:xfrm>
           <a:prstGeom prst="rect">
             <a:avLst/>
@@ -4129,8 +4129,8 @@
         </p:nvSpPr>
         <p:spPr>
           <a:xfrm>
-            <a:off x="228600" y="4962652"/>
-            <a:ext cx="1664208" cy="329184"/>
+            <a:off x="228600" y="5024947"/>
+            <a:ext cx="1664208" cy="361456"/>
           </a:xfrm>
           <a:prstGeom prst="rect">
             <a:avLst/>
@@ -4174,8 +4174,8 @@
         </p:nvSpPr>
         <p:spPr>
           <a:xfrm>
-            <a:off x="265176" y="4999228"/>
-            <a:ext cx="1591056" cy="256031"/>
+            <a:off x="265176" y="5061523"/>
+            <a:ext cx="1591056" cy="288304"/>
           </a:xfrm>
           <a:prstGeom prst="rect">
             <a:avLst/>
@@ -4190,7 +4190,7 @@
           <a:p>
             <a:pPr algn="l"/>
             <a:r>
-              <a:rPr sz="850" b="0" i="0" u="none">
+              <a:rPr sz="1000" b="0" i="0" u="none">
                 <a:solidFill>
                   <a:srgbClr val="1A1A1A"/>
                 </a:solidFill>
@@ -4209,8 +4209,8 @@
         </p:nvSpPr>
         <p:spPr>
           <a:xfrm>
-            <a:off x="1892808" y="4962652"/>
-            <a:ext cx="896112" cy="329184"/>
+            <a:off x="1892808" y="5024947"/>
+            <a:ext cx="896112" cy="361456"/>
           </a:xfrm>
           <a:prstGeom prst="rect">
             <a:avLst/>
@@ -4254,8 +4254,8 @@
         </p:nvSpPr>
         <p:spPr>
           <a:xfrm>
-            <a:off x="2788920" y="4962652"/>
-            <a:ext cx="3840480" cy="329184"/>
+            <a:off x="2788920" y="5024947"/>
+            <a:ext cx="3840480" cy="361456"/>
           </a:xfrm>
           <a:prstGeom prst="rect">
             <a:avLst/>
@@ -4299,8 +4299,8 @@
         </p:nvSpPr>
         <p:spPr>
           <a:xfrm>
-            <a:off x="228600" y="5291836"/>
-            <a:ext cx="1664208" cy="329184"/>
+            <a:off x="228600" y="5386404"/>
+            <a:ext cx="1664208" cy="361456"/>
           </a:xfrm>
           <a:prstGeom prst="rect">
             <a:avLst/>
@@ -4344,8 +4344,8 @@
         </p:nvSpPr>
         <p:spPr>
           <a:xfrm>
-            <a:off x="265176" y="5328412"/>
-            <a:ext cx="1591056" cy="256031"/>
+            <a:off x="265176" y="5422980"/>
+            <a:ext cx="1591056" cy="288304"/>
           </a:xfrm>
           <a:prstGeom prst="rect">
             <a:avLst/>
@@ -4360,7 +4360,7 @@
           <a:p>
             <a:pPr algn="l"/>
             <a:r>
-              <a:rPr sz="850" b="0" i="0" u="none">
+              <a:rPr sz="1000" b="0" i="0" u="none">
                 <a:solidFill>
                   <a:srgbClr val="1A1A1A"/>
                 </a:solidFill>
@@ -4379,8 +4379,8 @@
         </p:nvSpPr>
         <p:spPr>
           <a:xfrm>
-            <a:off x="1892808" y="5291836"/>
-            <a:ext cx="896112" cy="329184"/>
+            <a:off x="1892808" y="5386404"/>
+            <a:ext cx="896112" cy="361456"/>
           </a:xfrm>
           <a:prstGeom prst="rect">
             <a:avLst/>
@@ -4424,8 +4424,8 @@
         </p:nvSpPr>
         <p:spPr>
           <a:xfrm>
-            <a:off x="2788920" y="5291836"/>
-            <a:ext cx="3840480" cy="329184"/>
+            <a:off x="2788920" y="5386404"/>
+            <a:ext cx="3840480" cy="361456"/>
           </a:xfrm>
           <a:prstGeom prst="rect">
             <a:avLst/>
@@ -4469,8 +4469,8 @@
         </p:nvSpPr>
         <p:spPr>
           <a:xfrm>
-            <a:off x="228600" y="5621020"/>
-            <a:ext cx="1664208" cy="329184"/>
+            <a:off x="228600" y="5747861"/>
+            <a:ext cx="1664208" cy="576609"/>
           </a:xfrm>
           <a:prstGeom prst="rect">
             <a:avLst/>
@@ -4514,8 +4514,8 @@
         </p:nvSpPr>
         <p:spPr>
           <a:xfrm>
-            <a:off x="265176" y="5657596"/>
-            <a:ext cx="1591056" cy="256031"/>
+            <a:off x="265176" y="5784437"/>
+            <a:ext cx="1591056" cy="503457"/>
           </a:xfrm>
           <a:prstGeom prst="rect">
             <a:avLst/>
@@ -4530,7 +4530,7 @@
           <a:p>
             <a:pPr algn="l"/>
             <a:r>
-              <a:rPr sz="850" b="0" i="0" u="none">
+              <a:rPr sz="1000" b="0" i="0" u="none">
                 <a:solidFill>
                   <a:srgbClr val="1A1A1A"/>
                 </a:solidFill>
@@ -4549,8 +4549,8 @@
         </p:nvSpPr>
         <p:spPr>
           <a:xfrm>
-            <a:off x="1892808" y="5621020"/>
-            <a:ext cx="896112" cy="329184"/>
+            <a:off x="1892808" y="5747861"/>
+            <a:ext cx="896112" cy="576609"/>
           </a:xfrm>
           <a:prstGeom prst="rect">
             <a:avLst/>
@@ -4594,8 +4594,8 @@
         </p:nvSpPr>
         <p:spPr>
           <a:xfrm>
-            <a:off x="2788920" y="5621020"/>
-            <a:ext cx="3840480" cy="329184"/>
+            <a:off x="2788920" y="5747861"/>
+            <a:ext cx="3840480" cy="576609"/>
           </a:xfrm>
           <a:prstGeom prst="rect">
             <a:avLst/>
@@ -4639,8 +4639,8 @@
         </p:nvSpPr>
         <p:spPr>
           <a:xfrm>
-            <a:off x="228600" y="5950204"/>
-            <a:ext cx="1664208" cy="329184"/>
+            <a:off x="228600" y="6324471"/>
+            <a:ext cx="1664208" cy="361456"/>
           </a:xfrm>
           <a:prstGeom prst="rect">
             <a:avLst/>
@@ -4684,8 +4684,8 @@
         </p:nvSpPr>
         <p:spPr>
           <a:xfrm>
-            <a:off x="265176" y="5986780"/>
-            <a:ext cx="1591056" cy="256031"/>
+            <a:off x="265176" y="6361047"/>
+            <a:ext cx="1591056" cy="288304"/>
           </a:xfrm>
           <a:prstGeom prst="rect">
             <a:avLst/>
@@ -4700,7 +4700,7 @@
           <a:p>
             <a:pPr algn="l"/>
             <a:r>
-              <a:rPr sz="850" b="0" i="0" u="none">
+              <a:rPr sz="1000" b="0" i="0" u="none">
                 <a:solidFill>
                   <a:srgbClr val="1A1A1A"/>
                 </a:solidFill>
@@ -4719,8 +4719,8 @@
         </p:nvSpPr>
         <p:spPr>
           <a:xfrm>
-            <a:off x="1892808" y="5950204"/>
-            <a:ext cx="896112" cy="329184"/>
+            <a:off x="1892808" y="6324471"/>
+            <a:ext cx="896112" cy="361456"/>
           </a:xfrm>
           <a:prstGeom prst="rect">
             <a:avLst/>
@@ -4764,8 +4764,8 @@
         </p:nvSpPr>
         <p:spPr>
           <a:xfrm>
-            <a:off x="2788920" y="5950204"/>
-            <a:ext cx="3840480" cy="329184"/>
+            <a:off x="2788920" y="6324471"/>
+            <a:ext cx="3840480" cy="361456"/>
           </a:xfrm>
           <a:prstGeom prst="rect">
             <a:avLst/>
@@ -4809,8 +4809,8 @@
         </p:nvSpPr>
         <p:spPr>
           <a:xfrm>
-            <a:off x="228600" y="6389116"/>
-            <a:ext cx="6400800" cy="219456"/>
+            <a:off x="228600" y="6795656"/>
+            <a:ext cx="6400800" cy="256032"/>
           </a:xfrm>
           <a:prstGeom prst="rect">
             <a:avLst/>
@@ -4825,7 +4825,7 @@
           <a:p>
             <a:pPr algn="l"/>
             <a:r>
-              <a:rPr sz="1200" b="1" i="0" u="none">
+              <a:rPr sz="1400" b="1" i="0" u="none">
                 <a:solidFill>
                   <a:srgbClr val="1798D3"/>
                 </a:solidFill>
@@ -4844,8 +4844,8 @@
         </p:nvSpPr>
         <p:spPr>
           <a:xfrm>
-            <a:off x="228600" y="6663436"/>
-            <a:ext cx="6400800" cy="173736"/>
+            <a:off x="228600" y="7106552"/>
+            <a:ext cx="6400800" cy="192024"/>
           </a:xfrm>
           <a:prstGeom prst="rect">
             <a:avLst/>
@@ -4860,7 +4860,7 @@
           <a:p>
             <a:pPr algn="l"/>
             <a:r>
-              <a:rPr sz="950" b="0" i="0" u="none">
+              <a:rPr sz="1050" b="0" i="0" u="none">
                 <a:solidFill>
                   <a:srgbClr val="1A1A1A"/>
                 </a:solidFill>
@@ -4881,7 +4881,7 @@
         </p:nvSpPr>
         <p:spPr>
           <a:xfrm>
-            <a:off x="228600" y="6910324"/>
+            <a:off x="228600" y="7586612"/>
             <a:ext cx="6400800" cy="0"/>
           </a:xfrm>
           <a:prstGeom prst="line">
@@ -4911,7 +4911,7 @@
         </p:nvSpPr>
         <p:spPr>
           <a:xfrm>
-            <a:off x="228600" y="7198360"/>
+            <a:off x="228600" y="7874648"/>
             <a:ext cx="6400800" cy="0"/>
           </a:xfrm>
           <a:prstGeom prst="line">
@@ -4941,7 +4941,7 @@
         </p:nvSpPr>
         <p:spPr>
           <a:xfrm>
-            <a:off x="228600" y="7486396"/>
+            <a:off x="228600" y="8162684"/>
             <a:ext cx="6400800" cy="0"/>
           </a:xfrm>
           <a:prstGeom prst="line">
@@ -4969,8 +4969,8 @@
         </p:nvSpPr>
         <p:spPr>
           <a:xfrm>
-            <a:off x="228600" y="7911592"/>
-            <a:ext cx="6400800" cy="493776"/>
+            <a:off x="228600" y="8587880"/>
+            <a:ext cx="6400800" cy="615696"/>
           </a:xfrm>
           <a:prstGeom prst="rect">
             <a:avLst/>
@@ -5014,8 +5014,8 @@
         </p:nvSpPr>
         <p:spPr>
           <a:xfrm>
-            <a:off x="274320" y="7957312"/>
-            <a:ext cx="6309360" cy="420624"/>
+            <a:off x="274320" y="8633600"/>
+            <a:ext cx="6309360" cy="542544"/>
           </a:xfrm>
           <a:prstGeom prst="rect">
             <a:avLst/>
@@ -5029,7 +5029,7 @@
           <a:lstStyle/>
           <a:p>
             <a:r>
-              <a:rPr b="1" sz="900">
+              <a:rPr b="1" sz="1200">
                 <a:solidFill>
                   <a:srgbClr val="E67E22"/>
                 </a:solidFill>
@@ -5038,7 +5038,7 @@
               <a:t>Word bank: </a:t>
             </a:r>
             <a:r>
-              <a:rPr sz="900">
+              <a:rPr sz="1200">
                 <a:solidFill>
                   <a:srgbClr val="1A1A1A"/>
                 </a:solidFill>

</xml_diff>

<commit_message>
T6W7 L1 LP v4: recalibrate wrap-line ratio against real PowerPoint evidence, 12pt default for instruction text
</commit_message>
<xml_diff>
--- a/Science/T6W7_L1_LP1_Scientist_States_of_Matter.pptx
+++ b/Science/T6W7_L1_LP1_Scientist_States_of_Matter.pptx
@@ -3450,7 +3450,7 @@
         <p:spPr>
           <a:xfrm>
             <a:off x="228600" y="3579119"/>
-            <a:ext cx="1664208" cy="361456"/>
+            <a:ext cx="1664208" cy="329184"/>
           </a:xfrm>
           <a:prstGeom prst="rect">
             <a:avLst/>
@@ -3495,7 +3495,7 @@
         <p:spPr>
           <a:xfrm>
             <a:off x="265176" y="3615695"/>
-            <a:ext cx="1591056" cy="288304"/>
+            <a:ext cx="1591056" cy="256031"/>
           </a:xfrm>
           <a:prstGeom prst="rect">
             <a:avLst/>
@@ -3530,7 +3530,7 @@
         <p:spPr>
           <a:xfrm>
             <a:off x="1892808" y="3579119"/>
-            <a:ext cx="896112" cy="361456"/>
+            <a:ext cx="896112" cy="329184"/>
           </a:xfrm>
           <a:prstGeom prst="rect">
             <a:avLst/>
@@ -3575,7 +3575,7 @@
         <p:spPr>
           <a:xfrm>
             <a:off x="2788920" y="3579119"/>
-            <a:ext cx="3840480" cy="361456"/>
+            <a:ext cx="3840480" cy="329184"/>
           </a:xfrm>
           <a:prstGeom prst="rect">
             <a:avLst/>
@@ -3619,8 +3619,8 @@
         </p:nvSpPr>
         <p:spPr>
           <a:xfrm>
-            <a:off x="228600" y="3940576"/>
-            <a:ext cx="1664208" cy="361456"/>
+            <a:off x="228600" y="3908303"/>
+            <a:ext cx="1664208" cy="329184"/>
           </a:xfrm>
           <a:prstGeom prst="rect">
             <a:avLst/>
@@ -3664,8 +3664,8 @@
         </p:nvSpPr>
         <p:spPr>
           <a:xfrm>
-            <a:off x="265176" y="3977152"/>
-            <a:ext cx="1591056" cy="288304"/>
+            <a:off x="265176" y="3944879"/>
+            <a:ext cx="1591056" cy="256031"/>
           </a:xfrm>
           <a:prstGeom prst="rect">
             <a:avLst/>
@@ -3699,8 +3699,8 @@
         </p:nvSpPr>
         <p:spPr>
           <a:xfrm>
-            <a:off x="1892808" y="3940576"/>
-            <a:ext cx="896112" cy="361456"/>
+            <a:off x="1892808" y="3908303"/>
+            <a:ext cx="896112" cy="329184"/>
           </a:xfrm>
           <a:prstGeom prst="rect">
             <a:avLst/>
@@ -3744,8 +3744,8 @@
         </p:nvSpPr>
         <p:spPr>
           <a:xfrm>
-            <a:off x="2788920" y="3940576"/>
-            <a:ext cx="3840480" cy="361456"/>
+            <a:off x="2788920" y="3908303"/>
+            <a:ext cx="3840480" cy="329184"/>
           </a:xfrm>
           <a:prstGeom prst="rect">
             <a:avLst/>
@@ -3789,8 +3789,8 @@
         </p:nvSpPr>
         <p:spPr>
           <a:xfrm>
-            <a:off x="228600" y="4302033"/>
-            <a:ext cx="1664208" cy="361456"/>
+            <a:off x="228600" y="4237487"/>
+            <a:ext cx="1664208" cy="329184"/>
           </a:xfrm>
           <a:prstGeom prst="rect">
             <a:avLst/>
@@ -3834,8 +3834,8 @@
         </p:nvSpPr>
         <p:spPr>
           <a:xfrm>
-            <a:off x="265176" y="4338609"/>
-            <a:ext cx="1591056" cy="288304"/>
+            <a:off x="265176" y="4274063"/>
+            <a:ext cx="1591056" cy="256031"/>
           </a:xfrm>
           <a:prstGeom prst="rect">
             <a:avLst/>
@@ -3869,8 +3869,8 @@
         </p:nvSpPr>
         <p:spPr>
           <a:xfrm>
-            <a:off x="1892808" y="4302033"/>
-            <a:ext cx="896112" cy="361456"/>
+            <a:off x="1892808" y="4237487"/>
+            <a:ext cx="896112" cy="329184"/>
           </a:xfrm>
           <a:prstGeom prst="rect">
             <a:avLst/>
@@ -3914,8 +3914,8 @@
         </p:nvSpPr>
         <p:spPr>
           <a:xfrm>
-            <a:off x="2788920" y="4302033"/>
-            <a:ext cx="3840480" cy="361456"/>
+            <a:off x="2788920" y="4237487"/>
+            <a:ext cx="3840480" cy="329184"/>
           </a:xfrm>
           <a:prstGeom prst="rect">
             <a:avLst/>
@@ -3959,8 +3959,8 @@
         </p:nvSpPr>
         <p:spPr>
           <a:xfrm>
-            <a:off x="228600" y="4663490"/>
-            <a:ext cx="1664208" cy="361456"/>
+            <a:off x="228600" y="4566671"/>
+            <a:ext cx="1664208" cy="329184"/>
           </a:xfrm>
           <a:prstGeom prst="rect">
             <a:avLst/>
@@ -4004,8 +4004,8 @@
         </p:nvSpPr>
         <p:spPr>
           <a:xfrm>
-            <a:off x="265176" y="4700066"/>
-            <a:ext cx="1591056" cy="288304"/>
+            <a:off x="265176" y="4603247"/>
+            <a:ext cx="1591056" cy="256031"/>
           </a:xfrm>
           <a:prstGeom prst="rect">
             <a:avLst/>
@@ -4039,8 +4039,8 @@
         </p:nvSpPr>
         <p:spPr>
           <a:xfrm>
-            <a:off x="1892808" y="4663490"/>
-            <a:ext cx="896112" cy="361456"/>
+            <a:off x="1892808" y="4566671"/>
+            <a:ext cx="896112" cy="329184"/>
           </a:xfrm>
           <a:prstGeom prst="rect">
             <a:avLst/>
@@ -4084,8 +4084,8 @@
         </p:nvSpPr>
         <p:spPr>
           <a:xfrm>
-            <a:off x="2788920" y="4663490"/>
-            <a:ext cx="3840480" cy="361456"/>
+            <a:off x="2788920" y="4566671"/>
+            <a:ext cx="3840480" cy="329184"/>
           </a:xfrm>
           <a:prstGeom prst="rect">
             <a:avLst/>
@@ -4129,8 +4129,8 @@
         </p:nvSpPr>
         <p:spPr>
           <a:xfrm>
-            <a:off x="228600" y="5024947"/>
-            <a:ext cx="1664208" cy="361456"/>
+            <a:off x="228600" y="4895855"/>
+            <a:ext cx="1664208" cy="329184"/>
           </a:xfrm>
           <a:prstGeom prst="rect">
             <a:avLst/>
@@ -4174,8 +4174,8 @@
         </p:nvSpPr>
         <p:spPr>
           <a:xfrm>
-            <a:off x="265176" y="5061523"/>
-            <a:ext cx="1591056" cy="288304"/>
+            <a:off x="265176" y="4932431"/>
+            <a:ext cx="1591056" cy="256031"/>
           </a:xfrm>
           <a:prstGeom prst="rect">
             <a:avLst/>
@@ -4209,8 +4209,8 @@
         </p:nvSpPr>
         <p:spPr>
           <a:xfrm>
-            <a:off x="1892808" y="5024947"/>
-            <a:ext cx="896112" cy="361456"/>
+            <a:off x="1892808" y="4895855"/>
+            <a:ext cx="896112" cy="329184"/>
           </a:xfrm>
           <a:prstGeom prst="rect">
             <a:avLst/>
@@ -4254,8 +4254,8 @@
         </p:nvSpPr>
         <p:spPr>
           <a:xfrm>
-            <a:off x="2788920" y="5024947"/>
-            <a:ext cx="3840480" cy="361456"/>
+            <a:off x="2788920" y="4895855"/>
+            <a:ext cx="3840480" cy="329184"/>
           </a:xfrm>
           <a:prstGeom prst="rect">
             <a:avLst/>
@@ -4299,8 +4299,8 @@
         </p:nvSpPr>
         <p:spPr>
           <a:xfrm>
-            <a:off x="228600" y="5386404"/>
-            <a:ext cx="1664208" cy="361456"/>
+            <a:off x="228600" y="5225039"/>
+            <a:ext cx="1664208" cy="329184"/>
           </a:xfrm>
           <a:prstGeom prst="rect">
             <a:avLst/>
@@ -4344,8 +4344,8 @@
         </p:nvSpPr>
         <p:spPr>
           <a:xfrm>
-            <a:off x="265176" y="5422980"/>
-            <a:ext cx="1591056" cy="288304"/>
+            <a:off x="265176" y="5261615"/>
+            <a:ext cx="1591056" cy="256031"/>
           </a:xfrm>
           <a:prstGeom prst="rect">
             <a:avLst/>
@@ -4379,8 +4379,8 @@
         </p:nvSpPr>
         <p:spPr>
           <a:xfrm>
-            <a:off x="1892808" y="5386404"/>
-            <a:ext cx="896112" cy="361456"/>
+            <a:off x="1892808" y="5225039"/>
+            <a:ext cx="896112" cy="329184"/>
           </a:xfrm>
           <a:prstGeom prst="rect">
             <a:avLst/>
@@ -4424,8 +4424,8 @@
         </p:nvSpPr>
         <p:spPr>
           <a:xfrm>
-            <a:off x="2788920" y="5386404"/>
-            <a:ext cx="3840480" cy="361456"/>
+            <a:off x="2788920" y="5225039"/>
+            <a:ext cx="3840480" cy="329184"/>
           </a:xfrm>
           <a:prstGeom prst="rect">
             <a:avLst/>
@@ -4469,8 +4469,8 @@
         </p:nvSpPr>
         <p:spPr>
           <a:xfrm>
-            <a:off x="228600" y="5747861"/>
-            <a:ext cx="1664208" cy="576609"/>
+            <a:off x="228600" y="5554223"/>
+            <a:ext cx="1664208" cy="329184"/>
           </a:xfrm>
           <a:prstGeom prst="rect">
             <a:avLst/>
@@ -4514,8 +4514,8 @@
         </p:nvSpPr>
         <p:spPr>
           <a:xfrm>
-            <a:off x="265176" y="5784437"/>
-            <a:ext cx="1591056" cy="503457"/>
+            <a:off x="265176" y="5590799"/>
+            <a:ext cx="1591056" cy="256031"/>
           </a:xfrm>
           <a:prstGeom prst="rect">
             <a:avLst/>
@@ -4549,8 +4549,8 @@
         </p:nvSpPr>
         <p:spPr>
           <a:xfrm>
-            <a:off x="1892808" y="5747861"/>
-            <a:ext cx="896112" cy="576609"/>
+            <a:off x="1892808" y="5554223"/>
+            <a:ext cx="896112" cy="329184"/>
           </a:xfrm>
           <a:prstGeom prst="rect">
             <a:avLst/>
@@ -4594,8 +4594,8 @@
         </p:nvSpPr>
         <p:spPr>
           <a:xfrm>
-            <a:off x="2788920" y="5747861"/>
-            <a:ext cx="3840480" cy="576609"/>
+            <a:off x="2788920" y="5554223"/>
+            <a:ext cx="3840480" cy="329184"/>
           </a:xfrm>
           <a:prstGeom prst="rect">
             <a:avLst/>
@@ -4639,8 +4639,8 @@
         </p:nvSpPr>
         <p:spPr>
           <a:xfrm>
-            <a:off x="228600" y="6324471"/>
-            <a:ext cx="1664208" cy="361456"/>
+            <a:off x="228600" y="5883407"/>
+            <a:ext cx="1664208" cy="329184"/>
           </a:xfrm>
           <a:prstGeom prst="rect">
             <a:avLst/>
@@ -4684,8 +4684,8 @@
         </p:nvSpPr>
         <p:spPr>
           <a:xfrm>
-            <a:off x="265176" y="6361047"/>
-            <a:ext cx="1591056" cy="288304"/>
+            <a:off x="265176" y="5919983"/>
+            <a:ext cx="1591056" cy="256031"/>
           </a:xfrm>
           <a:prstGeom prst="rect">
             <a:avLst/>
@@ -4719,8 +4719,8 @@
         </p:nvSpPr>
         <p:spPr>
           <a:xfrm>
-            <a:off x="1892808" y="6324471"/>
-            <a:ext cx="896112" cy="361456"/>
+            <a:off x="1892808" y="5883407"/>
+            <a:ext cx="896112" cy="329184"/>
           </a:xfrm>
           <a:prstGeom prst="rect">
             <a:avLst/>
@@ -4764,8 +4764,8 @@
         </p:nvSpPr>
         <p:spPr>
           <a:xfrm>
-            <a:off x="2788920" y="6324471"/>
-            <a:ext cx="3840480" cy="361456"/>
+            <a:off x="2788920" y="5883407"/>
+            <a:ext cx="3840480" cy="329184"/>
           </a:xfrm>
           <a:prstGeom prst="rect">
             <a:avLst/>
@@ -4809,7 +4809,7 @@
         </p:nvSpPr>
         <p:spPr>
           <a:xfrm>
-            <a:off x="228600" y="6795656"/>
+            <a:off x="228600" y="6322319"/>
             <a:ext cx="6400800" cy="256032"/>
           </a:xfrm>
           <a:prstGeom prst="rect">
@@ -4844,8 +4844,8 @@
         </p:nvSpPr>
         <p:spPr>
           <a:xfrm>
-            <a:off x="228600" y="7106552"/>
-            <a:ext cx="6400800" cy="192024"/>
+            <a:off x="228600" y="6633215"/>
+            <a:ext cx="6400800" cy="219456"/>
           </a:xfrm>
           <a:prstGeom prst="rect">
             <a:avLst/>
@@ -4860,7 +4860,7 @@
           <a:p>
             <a:pPr algn="l"/>
             <a:r>
-              <a:rPr sz="1050" b="0" i="0" u="none">
+              <a:rPr sz="1200" b="0" i="0" u="none">
                 <a:solidFill>
                   <a:srgbClr val="1A1A1A"/>
                 </a:solidFill>
@@ -4881,7 +4881,7 @@
         </p:nvSpPr>
         <p:spPr>
           <a:xfrm>
-            <a:off x="228600" y="7586612"/>
+            <a:off x="228600" y="7140707"/>
             <a:ext cx="6400800" cy="0"/>
           </a:xfrm>
           <a:prstGeom prst="line">
@@ -4911,7 +4911,7 @@
         </p:nvSpPr>
         <p:spPr>
           <a:xfrm>
-            <a:off x="228600" y="7874648"/>
+            <a:off x="228600" y="7428743"/>
             <a:ext cx="6400800" cy="0"/>
           </a:xfrm>
           <a:prstGeom prst="line">
@@ -4941,7 +4941,7 @@
         </p:nvSpPr>
         <p:spPr>
           <a:xfrm>
-            <a:off x="228600" y="8162684"/>
+            <a:off x="228600" y="7716779"/>
             <a:ext cx="6400800" cy="0"/>
           </a:xfrm>
           <a:prstGeom prst="line">
@@ -4969,7 +4969,7 @@
         </p:nvSpPr>
         <p:spPr>
           <a:xfrm>
-            <a:off x="228600" y="8587880"/>
+            <a:off x="228600" y="8141975"/>
             <a:ext cx="6400800" cy="615696"/>
           </a:xfrm>
           <a:prstGeom prst="rect">
@@ -5014,7 +5014,7 @@
         </p:nvSpPr>
         <p:spPr>
           <a:xfrm>
-            <a:off x="274320" y="8633600"/>
+            <a:off x="274320" y="8187695"/>
             <a:ext cx="6309360" cy="542544"/>
           </a:xfrm>
           <a:prstGeom prst="rect">
@@ -5380,7 +5380,7 @@
         <p:spPr>
           <a:xfrm>
             <a:off x="265176" y="1234440"/>
-            <a:ext cx="1591056" cy="347472"/>
+            <a:ext cx="1591056" cy="201168"/>
           </a:xfrm>
           <a:prstGeom prst="rect">
             <a:avLst/>
@@ -5415,7 +5415,7 @@
         <p:spPr>
           <a:xfrm>
             <a:off x="1929384" y="1234440"/>
-            <a:ext cx="822960" cy="347472"/>
+            <a:ext cx="822960" cy="201168"/>
           </a:xfrm>
           <a:prstGeom prst="rect">
             <a:avLst/>
@@ -5450,7 +5450,7 @@
         <p:spPr>
           <a:xfrm>
             <a:off x="2825496" y="1234440"/>
-            <a:ext cx="3767328" cy="347472"/>
+            <a:ext cx="3767328" cy="201168"/>
           </a:xfrm>
           <a:prstGeom prst="rect">
             <a:avLst/>
@@ -5484,7 +5484,7 @@
         </p:nvSpPr>
         <p:spPr>
           <a:xfrm>
-            <a:off x="265176" y="1618488"/>
+            <a:off x="265176" y="1472184"/>
             <a:ext cx="1591056" cy="347472"/>
           </a:xfrm>
           <a:prstGeom prst="rect">
@@ -5519,7 +5519,7 @@
         </p:nvSpPr>
         <p:spPr>
           <a:xfrm>
-            <a:off x="1929384" y="1618488"/>
+            <a:off x="1929384" y="1472184"/>
             <a:ext cx="822960" cy="347472"/>
           </a:xfrm>
           <a:prstGeom prst="rect">
@@ -5554,7 +5554,7 @@
         </p:nvSpPr>
         <p:spPr>
           <a:xfrm>
-            <a:off x="2825496" y="1618488"/>
+            <a:off x="2825496" y="1472184"/>
             <a:ext cx="3767328" cy="347472"/>
           </a:xfrm>
           <a:prstGeom prst="rect">
@@ -5589,7 +5589,7 @@
         </p:nvSpPr>
         <p:spPr>
           <a:xfrm>
-            <a:off x="265176" y="2002536"/>
+            <a:off x="265176" y="1856232"/>
             <a:ext cx="1591056" cy="347472"/>
           </a:xfrm>
           <a:prstGeom prst="rect">
@@ -5624,7 +5624,7 @@
         </p:nvSpPr>
         <p:spPr>
           <a:xfrm>
-            <a:off x="1929384" y="2002536"/>
+            <a:off x="1929384" y="1856232"/>
             <a:ext cx="822960" cy="347472"/>
           </a:xfrm>
           <a:prstGeom prst="rect">
@@ -5659,7 +5659,7 @@
         </p:nvSpPr>
         <p:spPr>
           <a:xfrm>
-            <a:off x="2825496" y="2002536"/>
+            <a:off x="2825496" y="1856232"/>
             <a:ext cx="3767328" cy="347472"/>
           </a:xfrm>
           <a:prstGeom prst="rect">
@@ -5694,8 +5694,8 @@
         </p:nvSpPr>
         <p:spPr>
           <a:xfrm>
-            <a:off x="265176" y="2386584"/>
-            <a:ext cx="1591056" cy="347472"/>
+            <a:off x="265176" y="2240280"/>
+            <a:ext cx="1591056" cy="201168"/>
           </a:xfrm>
           <a:prstGeom prst="rect">
             <a:avLst/>
@@ -5729,8 +5729,8 @@
         </p:nvSpPr>
         <p:spPr>
           <a:xfrm>
-            <a:off x="1929384" y="2386584"/>
-            <a:ext cx="822960" cy="347472"/>
+            <a:off x="1929384" y="2240280"/>
+            <a:ext cx="822960" cy="201168"/>
           </a:xfrm>
           <a:prstGeom prst="rect">
             <a:avLst/>
@@ -5764,8 +5764,8 @@
         </p:nvSpPr>
         <p:spPr>
           <a:xfrm>
-            <a:off x="2825496" y="2386584"/>
-            <a:ext cx="3767328" cy="347472"/>
+            <a:off x="2825496" y="2240280"/>
+            <a:ext cx="3767328" cy="201168"/>
           </a:xfrm>
           <a:prstGeom prst="rect">
             <a:avLst/>
@@ -5799,7 +5799,7 @@
         </p:nvSpPr>
         <p:spPr>
           <a:xfrm>
-            <a:off x="265176" y="2770632"/>
+            <a:off x="265176" y="2478024"/>
             <a:ext cx="1591056" cy="347472"/>
           </a:xfrm>
           <a:prstGeom prst="rect">
@@ -5834,7 +5834,7 @@
         </p:nvSpPr>
         <p:spPr>
           <a:xfrm>
-            <a:off x="1929384" y="2770632"/>
+            <a:off x="1929384" y="2478024"/>
             <a:ext cx="822960" cy="347472"/>
           </a:xfrm>
           <a:prstGeom prst="rect">
@@ -5869,7 +5869,7 @@
         </p:nvSpPr>
         <p:spPr>
           <a:xfrm>
-            <a:off x="2825496" y="2770632"/>
+            <a:off x="2825496" y="2478024"/>
             <a:ext cx="3767328" cy="347472"/>
           </a:xfrm>
           <a:prstGeom prst="rect">
@@ -5904,7 +5904,7 @@
         </p:nvSpPr>
         <p:spPr>
           <a:xfrm>
-            <a:off x="265176" y="3154679"/>
+            <a:off x="265176" y="2862072"/>
             <a:ext cx="1591056" cy="347472"/>
           </a:xfrm>
           <a:prstGeom prst="rect">
@@ -5939,7 +5939,7 @@
         </p:nvSpPr>
         <p:spPr>
           <a:xfrm>
-            <a:off x="1929384" y="3154679"/>
+            <a:off x="1929384" y="2862072"/>
             <a:ext cx="822960" cy="347472"/>
           </a:xfrm>
           <a:prstGeom prst="rect">
@@ -5974,7 +5974,7 @@
         </p:nvSpPr>
         <p:spPr>
           <a:xfrm>
-            <a:off x="2825496" y="3154679"/>
+            <a:off x="2825496" y="2862072"/>
             <a:ext cx="3767328" cy="347472"/>
           </a:xfrm>
           <a:prstGeom prst="rect">
@@ -6009,8 +6009,8 @@
         </p:nvSpPr>
         <p:spPr>
           <a:xfrm>
-            <a:off x="265176" y="3538727"/>
-            <a:ext cx="1591056" cy="347472"/>
+            <a:off x="265176" y="3246120"/>
+            <a:ext cx="1591056" cy="201168"/>
           </a:xfrm>
           <a:prstGeom prst="rect">
             <a:avLst/>
@@ -6044,8 +6044,8 @@
         </p:nvSpPr>
         <p:spPr>
           <a:xfrm>
-            <a:off x="1929384" y="3538727"/>
-            <a:ext cx="822960" cy="347472"/>
+            <a:off x="1929384" y="3246120"/>
+            <a:ext cx="822960" cy="201168"/>
           </a:xfrm>
           <a:prstGeom prst="rect">
             <a:avLst/>
@@ -6079,8 +6079,8 @@
         </p:nvSpPr>
         <p:spPr>
           <a:xfrm>
-            <a:off x="2825496" y="3538727"/>
-            <a:ext cx="3767328" cy="347472"/>
+            <a:off x="2825496" y="3246120"/>
+            <a:ext cx="3767328" cy="201168"/>
           </a:xfrm>
           <a:prstGeom prst="rect">
             <a:avLst/>
@@ -6114,7 +6114,7 @@
         </p:nvSpPr>
         <p:spPr>
           <a:xfrm>
-            <a:off x="265176" y="3922775"/>
+            <a:off x="265176" y="3483864"/>
             <a:ext cx="1591056" cy="347472"/>
           </a:xfrm>
           <a:prstGeom prst="rect">
@@ -6149,7 +6149,7 @@
         </p:nvSpPr>
         <p:spPr>
           <a:xfrm>
-            <a:off x="1929384" y="3922775"/>
+            <a:off x="1929384" y="3483864"/>
             <a:ext cx="822960" cy="347472"/>
           </a:xfrm>
           <a:prstGeom prst="rect">
@@ -6184,7 +6184,7 @@
         </p:nvSpPr>
         <p:spPr>
           <a:xfrm>
-            <a:off x="2825496" y="3922775"/>
+            <a:off x="2825496" y="3483864"/>
             <a:ext cx="3767328" cy="347472"/>
           </a:xfrm>
           <a:prstGeom prst="rect">
@@ -6219,7 +6219,7 @@
         </p:nvSpPr>
         <p:spPr>
           <a:xfrm>
-            <a:off x="228600" y="4425696"/>
+            <a:off x="228600" y="3986784"/>
             <a:ext cx="6400800" cy="219456"/>
           </a:xfrm>
           <a:prstGeom prst="rect">
@@ -6254,7 +6254,7 @@
         </p:nvSpPr>
         <p:spPr>
           <a:xfrm>
-            <a:off x="228600" y="4700016"/>
+            <a:off x="228600" y="4261104"/>
             <a:ext cx="6400800" cy="173736"/>
           </a:xfrm>
           <a:prstGeom prst="rect">
@@ -6289,7 +6289,7 @@
         </p:nvSpPr>
         <p:spPr>
           <a:xfrm>
-            <a:off x="228600" y="4946904"/>
+            <a:off x="228600" y="4507992"/>
             <a:ext cx="6400800" cy="347472"/>
           </a:xfrm>
           <a:prstGeom prst="rect">
@@ -6324,8 +6324,8 @@
         </p:nvSpPr>
         <p:spPr>
           <a:xfrm>
-            <a:off x="228600" y="5367528"/>
-            <a:ext cx="6400800" cy="347472"/>
+            <a:off x="228600" y="4928616"/>
+            <a:ext cx="6400800" cy="173736"/>
           </a:xfrm>
           <a:prstGeom prst="rect">
             <a:avLst/>

</xml_diff>